<commit_message>
refactor: integrate structured tool wrappers in mcp_server and add real-time progress tracking UI to the chat interface
</commit_message>
<xml_diff>
--- a/docs/Idaho_AI_Executive_Pitch.pptx
+++ b/docs/Idaho_AI_Executive_Pitch.pptx
@@ -3666,7 +3666,7 @@
                 </a:solidFill>
                 <a:latin typeface="Calibri"/>
               </a:rPr>
-              <a:t>Approve Phase 1: Data Foundation &amp; IDHW-IDOC integration</a:t>
+              <a:t>Authorize Phase 5: Production hardening &amp; compliance certification</a:t>
             </a:r>
           </a:p>
         </p:txBody>
@@ -10268,7 +10268,7 @@
                 </a:solidFill>
                 <a:latin typeface="Calibri"/>
               </a:rPr>
-              <a:t>Establish data infrastructure, load agency data, validate insight_id linkage</a:t>
+              <a:t>✓ Data infrastructure built, agency CSV data loaded, insight_id validated</a:t>
             </a:r>
           </a:p>
         </p:txBody>
@@ -10623,7 +10623,7 @@
                 </a:solidFill>
                 <a:latin typeface="Calibri"/>
               </a:rPr>
-              <a:t>Deploy MCP servers for each agency, enabling secure programmatic access</a:t>
+              <a:t>✓ MCP servers deployed: 9+ tools per agency, /execute endpoints live</a:t>
             </a:r>
           </a:p>
         </p:txBody>
@@ -10978,7 +10978,7 @@
                 </a:solidFill>
                 <a:latin typeface="Calibri"/>
               </a:rPr>
-              <a:t>Deploy LangGraph orchestration engine, enable natural language queries</a:t>
+              <a:t>✓ LangGraph state machine running, natural language queries operational</a:t>
             </a:r>
           </a:p>
         </p:txBody>
@@ -11334,7 +11334,7 @@
                 </a:solidFill>
                 <a:latin typeface="Calibri"/>
               </a:rPr>
-              <a:t>Entity resolution, identity matching, cross-agency insight generation</a:t>
+              <a:t>Cross-agency reasoning, parent ID extraction, ephemeral graph analysis</a:t>
             </a:r>
           </a:p>
         </p:txBody>
@@ -11689,7 +11689,7 @@
                 </a:solidFill>
                 <a:latin typeface="Calibri"/>
               </a:rPr>
-              <a:t>Full production deployment, user training, compliance certification</a:t>
+              <a:t>Web UI, compliance certification, user training, production hardening</a:t>
             </a:r>
           </a:p>
         </p:txBody>
@@ -12019,7 +12019,7 @@
                 </a:solidFill>
                 <a:latin typeface="Calibri"/>
               </a:rPr>
-              <a:t>• Timeline: Production in 9-12 months</a:t>
+              <a:t>• Timeline: Core platform built, production in 3-6 months</a:t>
             </a:r>
           </a:p>
         </p:txBody>
@@ -12054,7 +12054,7 @@
                 </a:solidFill>
                 <a:latin typeface="Calibri"/>
               </a:rPr>
-              <a:t>• Maintenance: Low — AI model updates, not schema changes</a:t>
+              <a:t>• Web Interface: Real-time query UI with progress tracking</a:t>
             </a:r>
           </a:p>
         </p:txBody>

</xml_diff>